<commit_message>
Update PPT presentation and adjust program name in README
</commit_message>
<xml_diff>
--- a/Vishal Kumar Tripathi_VOIS_Major_Project_PPT_Submission.pptx
+++ b/Vishal Kumar Tripathi_VOIS_Major_Project_PPT_Submission.pptx
@@ -10208,7 +10208,7 @@
             </a:pPr>
             <a:r>
               <a:rPr sz="1400" dirty="0"/>
-              <a:t>VOIS AICTE Batch 1 (2026–2027)</a:t>
+              <a:t>VOIS AICTE Batch (2026–2027)</a:t>
             </a:r>
           </a:p>
         </p:txBody>
@@ -22974,21 +22974,21 @@
 </file>
 
 <file path=customXml/item1.xml><?xml version="1.0" encoding="utf-8"?>
+<?mso-contentType ?>
+<FormTemplates xmlns="http://schemas.microsoft.com/sharepoint/v3/contenttype/forms">
+  <Display>DocumentLibraryForm</Display>
+  <Edit>DocumentLibraryForm</Edit>
+  <New>DocumentLibraryForm</New>
+</FormTemplates>
+</file>
+
+<file path=customXml/item2.xml><?xml version="1.0" encoding="utf-8"?>
 <p:properties xmlns:p="http://schemas.microsoft.com/office/2006/metadata/properties" xmlns:xsi="http://www.w3.org/2001/XMLSchema-instance" xmlns:pc="http://schemas.microsoft.com/office/infopath/2007/PartnerControls">
   <documentManagement>
     <Status xmlns="71af3243-3dd4-4a8d-8c0d-dd76da1f02a5">Not started</Status>
     <MediaServiceKeyPoints xmlns="71af3243-3dd4-4a8d-8c0d-dd76da1f02a5" xsi:nil="true"/>
   </documentManagement>
 </p:properties>
-</file>
-
-<file path=customXml/item2.xml><?xml version="1.0" encoding="utf-8"?>
-<?mso-contentType ?>
-<FormTemplates xmlns="http://schemas.microsoft.com/sharepoint/v3/contenttype/forms">
-  <Display>DocumentLibraryForm</Display>
-  <Edit>DocumentLibraryForm</Edit>
-  <New>DocumentLibraryForm</New>
-</FormTemplates>
 </file>
 
 <file path=customXml/item3.xml><?xml version="1.0" encoding="utf-8"?>
@@ -23213,19 +23213,19 @@
 </file>
 
 <file path=customXml/itemProps1.xml><?xml version="1.0" encoding="utf-8"?>
+<ds:datastoreItem xmlns:ds="http://schemas.openxmlformats.org/officeDocument/2006/customXml" ds:itemID="{05D99ABA-76CE-4A8E-B5F0-C051B96628DE}">
+  <ds:schemaRefs>
+    <ds:schemaRef ds:uri="http://schemas.microsoft.com/sharepoint/v3/contenttype/forms"/>
+  </ds:schemaRefs>
+</ds:datastoreItem>
+</file>
+
+<file path=customXml/itemProps2.xml><?xml version="1.0" encoding="utf-8"?>
 <ds:datastoreItem xmlns:ds="http://schemas.openxmlformats.org/officeDocument/2006/customXml" ds:itemID="{4DEA9014-ED64-4558-B1E1-D03F0EE32BEB}">
   <ds:schemaRefs>
     <ds:schemaRef ds:uri="http://schemas.microsoft.com/office/2006/metadata/properties"/>
     <ds:schemaRef ds:uri="http://schemas.microsoft.com/office/infopath/2007/PartnerControls"/>
     <ds:schemaRef ds:uri="71af3243-3dd4-4a8d-8c0d-dd76da1f02a5"/>
-  </ds:schemaRefs>
-</ds:datastoreItem>
-</file>
-
-<file path=customXml/itemProps2.xml><?xml version="1.0" encoding="utf-8"?>
-<ds:datastoreItem xmlns:ds="http://schemas.openxmlformats.org/officeDocument/2006/customXml" ds:itemID="{05D99ABA-76CE-4A8E-B5F0-C051B96628DE}">
-  <ds:schemaRefs>
-    <ds:schemaRef ds:uri="http://schemas.microsoft.com/sharepoint/v3/contenttype/forms"/>
   </ds:schemaRefs>
 </ds:datastoreItem>
 </file>

</xml_diff>

<commit_message>
Update presentation PPT with latest local edits
</commit_message>
<xml_diff>
--- a/Vishal Kumar Tripathi_VOIS_Major_Project_PPT_Submission.pptx
+++ b/Vishal Kumar Tripathi_VOIS_Major_Project_PPT_Submission.pptx
@@ -10208,7 +10208,15 @@
             </a:pPr>
             <a:r>
               <a:rPr sz="1400" dirty="0"/>
-              <a:t>VOIS AICTE Batch (2026–2027)</a:t>
+              <a:t>VOIS AICTE </a:t>
+            </a:r>
+            <a:r>
+              <a:rPr lang="en-US" sz="1400" dirty="0"/>
+              <a:t>August </a:t>
+            </a:r>
+            <a:r>
+              <a:rPr sz="1400" dirty="0"/>
+              <a:t>Batch (2026–2027)</a:t>
             </a:r>
           </a:p>
         </p:txBody>
@@ -13513,7 +13521,7 @@
         <p:spPr>
           <a:xfrm>
             <a:off x="524486" y="1984579"/>
-            <a:ext cx="8209251" cy="3503523"/>
+            <a:ext cx="8209251" cy="3826689"/>
           </a:xfrm>
           <a:prstGeom prst="rect">
             <a:avLst/>
@@ -13556,7 +13564,31 @@
             </a:pPr>
             <a:r>
               <a:rPr sz="1600" dirty="0"/>
-              <a:t>Repository Name: Seasonal-Agriculture-Performance-Analysis</a:t>
+              <a:t>Repository Name: Seasonal</a:t>
+            </a:r>
+            <a:r>
+              <a:rPr lang="en-US" sz="1600" dirty="0"/>
+              <a:t>_</a:t>
+            </a:r>
+            <a:r>
+              <a:rPr sz="1600" dirty="0"/>
+              <a:t>Agriculture</a:t>
+            </a:r>
+            <a:r>
+              <a:rPr lang="en-US" sz="1600" dirty="0"/>
+              <a:t>_</a:t>
+            </a:r>
+            <a:r>
+              <a:rPr sz="1600" dirty="0"/>
+              <a:t>Performance</a:t>
+            </a:r>
+            <a:r>
+              <a:rPr lang="en-US" sz="1600" dirty="0"/>
+              <a:t>_</a:t>
+            </a:r>
+            <a:r>
+              <a:rPr sz="1600" dirty="0"/>
+              <a:t>Analysis</a:t>
             </a:r>
           </a:p>
           <a:p>
@@ -13613,6 +13645,24 @@
               <a:t>Repository Files Included:</a:t>
             </a:r>
             <a:endParaRPr lang="en-US" sz="1600" dirty="0"/>
+          </a:p>
+          <a:p>
+            <a:pPr marL="342900" indent="-342900">
+              <a:spcAft>
+                <a:spcPts val="600"/>
+              </a:spcAft>
+              <a:buFont typeface="+mj-lt"/>
+              <a:buAutoNum type="arabicPeriod"/>
+              <a:defRPr sz="1300">
+                <a:solidFill>
+                  <a:srgbClr val="282828"/>
+                </a:solidFill>
+              </a:defRPr>
+            </a:pPr>
+            <a:r>
+              <a:rPr lang="en-US" sz="1600" dirty="0"/>
+              <a:t>Major Project_Seasonal Agriculture Performance Analysis.pdf</a:t>
+            </a:r>
           </a:p>
           <a:p>
             <a:pPr marL="342900" indent="-342900">
@@ -16288,7 +16338,15 @@
             </a:br>
             <a:r>
               <a:rPr dirty="0"/>
-              <a:t>VOIS AICTE Internship Batch (2026–2027)</a:t>
+              <a:t>VOIS AICTE Internship </a:t>
+            </a:r>
+            <a:r>
+              <a:rPr lang="en-US" dirty="0"/>
+              <a:t>August </a:t>
+            </a:r>
+            <a:r>
+              <a:rPr dirty="0"/>
+              <a:t>Batch (2026–2027)</a:t>
             </a:r>
             <a:br>
               <a:rPr dirty="0"/>
@@ -16858,7 +16916,7 @@
         <p:spPr>
           <a:xfrm>
             <a:off x="1036764" y="2306877"/>
-            <a:ext cx="6431280" cy="3607987"/>
+            <a:ext cx="6431280" cy="3058753"/>
           </a:xfrm>
         </p:spPr>
         <p:txBody>
@@ -22974,21 +23032,21 @@
 </file>
 
 <file path=customXml/item1.xml><?xml version="1.0" encoding="utf-8"?>
+<p:properties xmlns:p="http://schemas.microsoft.com/office/2006/metadata/properties" xmlns:xsi="http://www.w3.org/2001/XMLSchema-instance" xmlns:pc="http://schemas.microsoft.com/office/infopath/2007/PartnerControls">
+  <documentManagement>
+    <Status xmlns="71af3243-3dd4-4a8d-8c0d-dd76da1f02a5">Not started</Status>
+    <MediaServiceKeyPoints xmlns="71af3243-3dd4-4a8d-8c0d-dd76da1f02a5" xsi:nil="true"/>
+  </documentManagement>
+</p:properties>
+</file>
+
+<file path=customXml/item2.xml><?xml version="1.0" encoding="utf-8"?>
 <?mso-contentType ?>
 <FormTemplates xmlns="http://schemas.microsoft.com/sharepoint/v3/contenttype/forms">
   <Display>DocumentLibraryForm</Display>
   <Edit>DocumentLibraryForm</Edit>
   <New>DocumentLibraryForm</New>
 </FormTemplates>
-</file>
-
-<file path=customXml/item2.xml><?xml version="1.0" encoding="utf-8"?>
-<p:properties xmlns:p="http://schemas.microsoft.com/office/2006/metadata/properties" xmlns:xsi="http://www.w3.org/2001/XMLSchema-instance" xmlns:pc="http://schemas.microsoft.com/office/infopath/2007/PartnerControls">
-  <documentManagement>
-    <Status xmlns="71af3243-3dd4-4a8d-8c0d-dd76da1f02a5">Not started</Status>
-    <MediaServiceKeyPoints xmlns="71af3243-3dd4-4a8d-8c0d-dd76da1f02a5" xsi:nil="true"/>
-  </documentManagement>
-</p:properties>
 </file>
 
 <file path=customXml/item3.xml><?xml version="1.0" encoding="utf-8"?>
@@ -23213,19 +23271,19 @@
 </file>
 
 <file path=customXml/itemProps1.xml><?xml version="1.0" encoding="utf-8"?>
-<ds:datastoreItem xmlns:ds="http://schemas.openxmlformats.org/officeDocument/2006/customXml" ds:itemID="{05D99ABA-76CE-4A8E-B5F0-C051B96628DE}">
+<ds:datastoreItem xmlns:ds="http://schemas.openxmlformats.org/officeDocument/2006/customXml" ds:itemID="{4DEA9014-ED64-4558-B1E1-D03F0EE32BEB}">
   <ds:schemaRefs>
-    <ds:schemaRef ds:uri="http://schemas.microsoft.com/sharepoint/v3/contenttype/forms"/>
+    <ds:schemaRef ds:uri="http://schemas.microsoft.com/office/2006/metadata/properties"/>
+    <ds:schemaRef ds:uri="http://schemas.microsoft.com/office/infopath/2007/PartnerControls"/>
+    <ds:schemaRef ds:uri="71af3243-3dd4-4a8d-8c0d-dd76da1f02a5"/>
   </ds:schemaRefs>
 </ds:datastoreItem>
 </file>
 
 <file path=customXml/itemProps2.xml><?xml version="1.0" encoding="utf-8"?>
-<ds:datastoreItem xmlns:ds="http://schemas.openxmlformats.org/officeDocument/2006/customXml" ds:itemID="{4DEA9014-ED64-4558-B1E1-D03F0EE32BEB}">
+<ds:datastoreItem xmlns:ds="http://schemas.openxmlformats.org/officeDocument/2006/customXml" ds:itemID="{05D99ABA-76CE-4A8E-B5F0-C051B96628DE}">
   <ds:schemaRefs>
-    <ds:schemaRef ds:uri="http://schemas.microsoft.com/office/2006/metadata/properties"/>
-    <ds:schemaRef ds:uri="http://schemas.microsoft.com/office/infopath/2007/PartnerControls"/>
-    <ds:schemaRef ds:uri="71af3243-3dd4-4a8d-8c0d-dd76da1f02a5"/>
+    <ds:schemaRef ds:uri="http://schemas.microsoft.com/sharepoint/v3/contenttype/forms"/>
   </ds:schemaRefs>
 </ds:datastoreItem>
 </file>

</xml_diff>